<commit_message>
Date: 05 May 2026
</commit_message>
<xml_diff>
--- a/Data Driven Framework.pptx
+++ b/Data Driven Framework.pptx
@@ -10,6 +10,7 @@
     <p:sldId id="258" r:id="rId4"/>
     <p:sldId id="259" r:id="rId5"/>
     <p:sldId id="260" r:id="rId6"/>
+    <p:sldId id="261" r:id="rId7"/>
   </p:sldIdLst>
   <p:sldSz cx="12192000" cy="6858000"/>
   <p:notesSz cx="6858000" cy="9144000"/>
@@ -108,6 +109,11 @@
       </a:defRPr>
     </a:lvl9pPr>
   </p:defaultTextStyle>
+  <p:extLst>
+    <p:ext uri="{EFAFB233-063F-42B5-8137-9DF3F51BA10A}">
+      <p15:sldGuideLst xmlns:p15="http://schemas.microsoft.com/office/powerpoint/2012/main"/>
+    </p:ext>
+  </p:extLst>
 </p:presentation>
 </file>
 
@@ -1982,14 +1988,35 @@
         </dgm:presLayoutVars>
       </dgm:prSet>
       <dgm:spPr/>
+      <dgm:t>
+        <a:bodyPr/>
+        <a:lstStyle/>
+        <a:p>
+          <a:endParaRPr lang="en-IN"/>
+        </a:p>
+      </dgm:t>
     </dgm:pt>
     <dgm:pt modelId="{6A7A5DD3-EB9A-4E63-BEE1-507FFE0AB082}" type="pres">
       <dgm:prSet presAssocID="{5E23A796-0095-41AB-A621-B9E332A3F50B}" presName="sibTrans" presStyleLbl="sibTrans2D1" presStyleIdx="0" presStyleCnt="3"/>
       <dgm:spPr/>
+      <dgm:t>
+        <a:bodyPr/>
+        <a:lstStyle/>
+        <a:p>
+          <a:endParaRPr lang="en-IN"/>
+        </a:p>
+      </dgm:t>
     </dgm:pt>
     <dgm:pt modelId="{8C83346C-C4E8-4491-9915-E41352909422}" type="pres">
       <dgm:prSet presAssocID="{5E23A796-0095-41AB-A621-B9E332A3F50B}" presName="connectorText" presStyleLbl="sibTrans2D1" presStyleIdx="0" presStyleCnt="3"/>
       <dgm:spPr/>
+      <dgm:t>
+        <a:bodyPr/>
+        <a:lstStyle/>
+        <a:p>
+          <a:endParaRPr lang="en-IN"/>
+        </a:p>
+      </dgm:t>
     </dgm:pt>
     <dgm:pt modelId="{FE54B7A4-4562-4EE5-B776-C29171E4BE26}" type="pres">
       <dgm:prSet presAssocID="{3367D722-AED0-4C27-B0D7-291936ABF5DA}" presName="node" presStyleLbl="node1" presStyleIdx="1" presStyleCnt="4">
@@ -1998,14 +2025,35 @@
         </dgm:presLayoutVars>
       </dgm:prSet>
       <dgm:spPr/>
+      <dgm:t>
+        <a:bodyPr/>
+        <a:lstStyle/>
+        <a:p>
+          <a:endParaRPr lang="en-IN"/>
+        </a:p>
+      </dgm:t>
     </dgm:pt>
     <dgm:pt modelId="{FB0B3D66-E41A-4751-826F-82A8ED1E355C}" type="pres">
       <dgm:prSet presAssocID="{8C1B3EB5-8DCA-42DB-A991-B89EB3052C3B}" presName="sibTrans" presStyleLbl="sibTrans2D1" presStyleIdx="1" presStyleCnt="3"/>
       <dgm:spPr/>
+      <dgm:t>
+        <a:bodyPr/>
+        <a:lstStyle/>
+        <a:p>
+          <a:endParaRPr lang="en-IN"/>
+        </a:p>
+      </dgm:t>
     </dgm:pt>
     <dgm:pt modelId="{3F5354CE-04A2-4D4F-BB51-69FAA9AAB166}" type="pres">
       <dgm:prSet presAssocID="{8C1B3EB5-8DCA-42DB-A991-B89EB3052C3B}" presName="connectorText" presStyleLbl="sibTrans2D1" presStyleIdx="1" presStyleCnt="3"/>
       <dgm:spPr/>
+      <dgm:t>
+        <a:bodyPr/>
+        <a:lstStyle/>
+        <a:p>
+          <a:endParaRPr lang="en-IN"/>
+        </a:p>
+      </dgm:t>
     </dgm:pt>
     <dgm:pt modelId="{A4AD8D45-44BF-473B-A7AF-D918E0B89EAE}" type="pres">
       <dgm:prSet presAssocID="{A428DA78-CE0E-4446-8228-33A5B86DD72C}" presName="node" presStyleLbl="node1" presStyleIdx="2" presStyleCnt="4">
@@ -2014,14 +2062,35 @@
         </dgm:presLayoutVars>
       </dgm:prSet>
       <dgm:spPr/>
+      <dgm:t>
+        <a:bodyPr/>
+        <a:lstStyle/>
+        <a:p>
+          <a:endParaRPr lang="en-IN"/>
+        </a:p>
+      </dgm:t>
     </dgm:pt>
     <dgm:pt modelId="{FB8A97AC-80F7-472B-B743-A9256B345824}" type="pres">
       <dgm:prSet presAssocID="{9EBA303E-1B88-40B3-B7BB-B8933C7F3238}" presName="sibTrans" presStyleLbl="sibTrans2D1" presStyleIdx="2" presStyleCnt="3"/>
       <dgm:spPr/>
+      <dgm:t>
+        <a:bodyPr/>
+        <a:lstStyle/>
+        <a:p>
+          <a:endParaRPr lang="en-IN"/>
+        </a:p>
+      </dgm:t>
     </dgm:pt>
     <dgm:pt modelId="{E1DA9C88-5969-4D5B-90C9-B9FD31BFBF12}" type="pres">
       <dgm:prSet presAssocID="{9EBA303E-1B88-40B3-B7BB-B8933C7F3238}" presName="connectorText" presStyleLbl="sibTrans2D1" presStyleIdx="2" presStyleCnt="3"/>
       <dgm:spPr/>
+      <dgm:t>
+        <a:bodyPr/>
+        <a:lstStyle/>
+        <a:p>
+          <a:endParaRPr lang="en-IN"/>
+        </a:p>
+      </dgm:t>
     </dgm:pt>
     <dgm:pt modelId="{85D29FCF-7ECB-433D-BF55-6446DF3887D5}" type="pres">
       <dgm:prSet presAssocID="{6EA605E4-DEDA-44D6-A957-D6E707459D3C}" presName="node" presStyleLbl="node1" presStyleIdx="3" presStyleCnt="4">
@@ -2030,6 +2099,13 @@
         </dgm:presLayoutVars>
       </dgm:prSet>
       <dgm:spPr/>
+      <dgm:t>
+        <a:bodyPr/>
+        <a:lstStyle/>
+        <a:p>
+          <a:endParaRPr lang="en-IN"/>
+        </a:p>
+      </dgm:t>
     </dgm:pt>
   </dgm:ptLst>
   <dgm:cxnLst>
@@ -2044,9 +2120,9 @@
     <dgm:cxn modelId="{B54F718D-4FAF-4923-B57B-70972A1CF3CA}" type="presOf" srcId="{8C1B3EB5-8DCA-42DB-A991-B89EB3052C3B}" destId="{FB0B3D66-E41A-4751-826F-82A8ED1E355C}" srcOrd="0" destOrd="0" presId="urn:microsoft.com/office/officeart/2005/8/layout/process2"/>
     <dgm:cxn modelId="{1B8CF158-CF0B-4E9E-9225-806DB513ADC3}" type="presOf" srcId="{5E23A796-0095-41AB-A621-B9E332A3F50B}" destId="{6A7A5DD3-EB9A-4E63-BEE1-507FFE0AB082}" srcOrd="0" destOrd="0" presId="urn:microsoft.com/office/officeart/2005/8/layout/process2"/>
     <dgm:cxn modelId="{97EE997E-EC57-4725-9368-D2531FA93F0C}" srcId="{C9C092C0-D3AC-4E5F-8422-314FB380BA72}" destId="{6EA605E4-DEDA-44D6-A957-D6E707459D3C}" srcOrd="3" destOrd="0" parTransId="{0AFB2A4C-908B-4D65-8222-D4983F3AF177}" sibTransId="{B7B92C49-D94E-42C0-B2F2-35A5368A0AFC}"/>
+    <dgm:cxn modelId="{5C260AAA-E5FF-40FF-A0B1-4D785B6AC9FC}" type="presOf" srcId="{8C1B3EB5-8DCA-42DB-A991-B89EB3052C3B}" destId="{3F5354CE-04A2-4D4F-BB51-69FAA9AAB166}" srcOrd="1" destOrd="0" presId="urn:microsoft.com/office/officeart/2005/8/layout/process2"/>
     <dgm:cxn modelId="{1976D973-0ECA-42D8-83A0-5A436EEA8600}" srcId="{C9C092C0-D3AC-4E5F-8422-314FB380BA72}" destId="{A428DA78-CE0E-4446-8228-33A5B86DD72C}" srcOrd="2" destOrd="0" parTransId="{44F8D603-045E-472D-B74C-213D12C8EAEF}" sibTransId="{9EBA303E-1B88-40B3-B7BB-B8933C7F3238}"/>
     <dgm:cxn modelId="{5FC8799B-0A10-49B1-830A-CE8C336528EA}" type="presOf" srcId="{3367D722-AED0-4C27-B0D7-291936ABF5DA}" destId="{FE54B7A4-4562-4EE5-B776-C29171E4BE26}" srcOrd="0" destOrd="0" presId="urn:microsoft.com/office/officeart/2005/8/layout/process2"/>
-    <dgm:cxn modelId="{5C260AAA-E5FF-40FF-A0B1-4D785B6AC9FC}" type="presOf" srcId="{8C1B3EB5-8DCA-42DB-A991-B89EB3052C3B}" destId="{3F5354CE-04A2-4D4F-BB51-69FAA9AAB166}" srcOrd="1" destOrd="0" presId="urn:microsoft.com/office/officeart/2005/8/layout/process2"/>
     <dgm:cxn modelId="{42C3FF54-BDDD-44D5-BD2E-B6641FEB5D11}" type="presOf" srcId="{A428DA78-CE0E-4446-8228-33A5B86DD72C}" destId="{A4AD8D45-44BF-473B-A7AF-D918E0B89EAE}" srcOrd="0" destOrd="0" presId="urn:microsoft.com/office/officeart/2005/8/layout/process2"/>
     <dgm:cxn modelId="{65640A7D-B754-47FB-89D1-A0288F98A956}" type="presParOf" srcId="{B10F4FB4-738A-4FF9-B494-9F6417D7F3A1}" destId="{0836112E-AB14-4FF8-AE25-E041FF8788DF}" srcOrd="0" destOrd="0" presId="urn:microsoft.com/office/officeart/2005/8/layout/process2"/>
     <dgm:cxn modelId="{DD72680B-BAE8-46B8-9DBB-8E5A6EF9FBF6}" type="presParOf" srcId="{B10F4FB4-738A-4FF9-B494-9F6417D7F3A1}" destId="{6A7A5DD3-EB9A-4E63-BEE1-507FFE0AB082}" srcOrd="1" destOrd="0" presId="urn:microsoft.com/office/officeart/2005/8/layout/process2"/>
@@ -2169,6 +2245,13 @@
         </dgm:presLayoutVars>
       </dgm:prSet>
       <dgm:spPr/>
+      <dgm:t>
+        <a:bodyPr/>
+        <a:lstStyle/>
+        <a:p>
+          <a:endParaRPr lang="en-IN"/>
+        </a:p>
+      </dgm:t>
     </dgm:pt>
     <dgm:pt modelId="{3E4B8DA2-4E97-4293-BA62-AD39D26CA451}" type="pres">
       <dgm:prSet presAssocID="{7BDFB462-D9E2-4930-B87C-61F157CA9F29}" presName="parTxOnlySpace" presStyleCnt="0"/>
@@ -2193,11 +2276,11 @@
     </dgm:pt>
   </dgm:ptLst>
   <dgm:cxnLst>
-    <dgm:cxn modelId="{C85F0A1F-AA16-48D0-BB4C-419066CDD534}" type="presOf" srcId="{94AA305A-D88B-421A-A694-BBF8026B5186}" destId="{183EBBB6-F4B4-4E36-B79E-661D896DA0AE}" srcOrd="0" destOrd="0" presId="urn:microsoft.com/office/officeart/2005/8/layout/chevron1"/>
+    <dgm:cxn modelId="{4E7B5B3E-2364-45D5-831A-B458AC115333}" srcId="{34690CCD-E2BF-4EE7-8AAD-546BA45EA083}" destId="{DA7F3C77-B0DB-44D3-8C46-688D39CB8E68}" srcOrd="1" destOrd="0" parTransId="{00D3EE88-AB75-4C40-98CE-C46713E80BFC}" sibTransId="{5300C755-BDDE-4131-B10E-F81830F059EB}"/>
+    <dgm:cxn modelId="{A72123A7-EEA7-4A07-B6D9-017CCCBB62C5}" type="presOf" srcId="{DA7F3C77-B0DB-44D3-8C46-688D39CB8E68}" destId="{3720074F-BFB7-4535-BE55-9EE1EAF465AD}" srcOrd="0" destOrd="0" presId="urn:microsoft.com/office/officeart/2005/8/layout/chevron1"/>
     <dgm:cxn modelId="{5E4203A3-8CA6-4D56-8AAF-4B9959C11A8F}" type="presOf" srcId="{34690CCD-E2BF-4EE7-8AAD-546BA45EA083}" destId="{3473EFA3-E000-4F3D-830E-592CE7C23A72}" srcOrd="0" destOrd="0" presId="urn:microsoft.com/office/officeart/2005/8/layout/chevron1"/>
     <dgm:cxn modelId="{7AED9A43-F257-4306-B9B6-541C983F3C5A}" srcId="{34690CCD-E2BF-4EE7-8AAD-546BA45EA083}" destId="{94AA305A-D88B-421A-A694-BBF8026B5186}" srcOrd="0" destOrd="0" parTransId="{47819105-9FA0-4D5C-A1E2-B4F047CDD406}" sibTransId="{7BDFB462-D9E2-4930-B87C-61F157CA9F29}"/>
-    <dgm:cxn modelId="{4E7B5B3E-2364-45D5-831A-B458AC115333}" srcId="{34690CCD-E2BF-4EE7-8AAD-546BA45EA083}" destId="{DA7F3C77-B0DB-44D3-8C46-688D39CB8E68}" srcOrd="1" destOrd="0" parTransId="{00D3EE88-AB75-4C40-98CE-C46713E80BFC}" sibTransId="{5300C755-BDDE-4131-B10E-F81830F059EB}"/>
-    <dgm:cxn modelId="{A72123A7-EEA7-4A07-B6D9-017CCCBB62C5}" type="presOf" srcId="{DA7F3C77-B0DB-44D3-8C46-688D39CB8E68}" destId="{3720074F-BFB7-4535-BE55-9EE1EAF465AD}" srcOrd="0" destOrd="0" presId="urn:microsoft.com/office/officeart/2005/8/layout/chevron1"/>
+    <dgm:cxn modelId="{C85F0A1F-AA16-48D0-BB4C-419066CDD534}" type="presOf" srcId="{94AA305A-D88B-421A-A694-BBF8026B5186}" destId="{183EBBB6-F4B4-4E36-B79E-661D896DA0AE}" srcOrd="0" destOrd="0" presId="urn:microsoft.com/office/officeart/2005/8/layout/chevron1"/>
     <dgm:cxn modelId="{345E8EE6-9AD6-4D22-8C9E-7CAF2176860F}" type="presParOf" srcId="{3473EFA3-E000-4F3D-830E-592CE7C23A72}" destId="{183EBBB6-F4B4-4E36-B79E-661D896DA0AE}" srcOrd="0" destOrd="0" presId="urn:microsoft.com/office/officeart/2005/8/layout/chevron1"/>
     <dgm:cxn modelId="{82BA6E33-629F-4FFA-A29A-04C14D149291}" type="presParOf" srcId="{3473EFA3-E000-4F3D-830E-592CE7C23A72}" destId="{3E4B8DA2-4E97-4293-BA62-AD39D26CA451}" srcOrd="1" destOrd="0" presId="urn:microsoft.com/office/officeart/2005/8/layout/chevron1"/>
     <dgm:cxn modelId="{C2F30EB0-C0E0-4F0C-9186-07DA4236394A}" type="presParOf" srcId="{3473EFA3-E000-4F3D-830E-592CE7C23A72}" destId="{3720074F-BFB7-4535-BE55-9EE1EAF465AD}" srcOrd="2" destOrd="0" presId="urn:microsoft.com/office/officeart/2005/8/layout/chevron1"/>
@@ -6530,7 +6613,7 @@
             <a:fld id="{B61BEF0D-F0BB-DE4B-95CE-6DB70DBA9567}" type="datetimeFigureOut">
               <a:rPr lang="en-US" dirty="0"/>
               <a:pPr/>
-              <a:t>4/30/2026</a:t>
+              <a:t>5/5/2026</a:t>
             </a:fld>
             <a:endParaRPr lang="en-US" dirty="0"/>
           </a:p>
@@ -6778,7 +6861,7 @@
             <a:fld id="{B61BEF0D-F0BB-DE4B-95CE-6DB70DBA9567}" type="datetimeFigureOut">
               <a:rPr lang="en-US" dirty="0"/>
               <a:pPr/>
-              <a:t>4/30/2026</a:t>
+              <a:t>5/5/2026</a:t>
             </a:fld>
             <a:endParaRPr lang="en-US" dirty="0"/>
           </a:p>
@@ -7089,7 +7172,7 @@
             <a:fld id="{B61BEF0D-F0BB-DE4B-95CE-6DB70DBA9567}" type="datetimeFigureOut">
               <a:rPr lang="en-US" dirty="0"/>
               <a:pPr/>
-              <a:t>4/30/2026</a:t>
+              <a:t>5/5/2026</a:t>
             </a:fld>
             <a:endParaRPr lang="en-US" dirty="0"/>
           </a:p>
@@ -7427,7 +7510,7 @@
             <a:fld id="{B61BEF0D-F0BB-DE4B-95CE-6DB70DBA9567}" type="datetimeFigureOut">
               <a:rPr lang="en-US" dirty="0"/>
               <a:pPr/>
-              <a:t>4/30/2026</a:t>
+              <a:t>5/5/2026</a:t>
             </a:fld>
             <a:endParaRPr lang="en-US" dirty="0"/>
           </a:p>
@@ -7738,7 +7821,7 @@
             <a:fld id="{B61BEF0D-F0BB-DE4B-95CE-6DB70DBA9567}" type="datetimeFigureOut">
               <a:rPr lang="en-US" dirty="0"/>
               <a:pPr/>
-              <a:t>4/30/2026</a:t>
+              <a:t>5/5/2026</a:t>
             </a:fld>
             <a:endParaRPr lang="en-US" dirty="0"/>
           </a:p>
@@ -8128,7 +8211,7 @@
             <a:fld id="{B61BEF0D-F0BB-DE4B-95CE-6DB70DBA9567}" type="datetimeFigureOut">
               <a:rPr lang="en-US" dirty="0"/>
               <a:pPr/>
-              <a:t>4/30/2026</a:t>
+              <a:t>5/5/2026</a:t>
             </a:fld>
             <a:endParaRPr lang="en-US" dirty="0"/>
           </a:p>
@@ -8294,7 +8377,7 @@
           <a:p>
             <a:fld id="{55C6B4A9-1611-4792-9094-5F34BCA07E0B}" type="datetimeFigureOut">
               <a:rPr lang="en-US" dirty="0"/>
-              <a:t>4/30/2026</a:t>
+              <a:t>5/5/2026</a:t>
             </a:fld>
             <a:endParaRPr lang="en-US" dirty="0"/>
           </a:p>
@@ -8470,7 +8553,7 @@
             <a:fld id="{B61BEF0D-F0BB-DE4B-95CE-6DB70DBA9567}" type="datetimeFigureOut">
               <a:rPr lang="en-US" dirty="0"/>
               <a:pPr/>
-              <a:t>4/30/2026</a:t>
+              <a:t>5/5/2026</a:t>
             </a:fld>
             <a:endParaRPr lang="en-US" dirty="0"/>
           </a:p>
@@ -8643,7 +8726,7 @@
             <a:fld id="{B61BEF0D-F0BB-DE4B-95CE-6DB70DBA9567}" type="datetimeFigureOut">
               <a:rPr lang="en-US" dirty="0"/>
               <a:pPr/>
-              <a:t>4/30/2026</a:t>
+              <a:t>5/5/2026</a:t>
             </a:fld>
             <a:endParaRPr lang="en-US" dirty="0"/>
           </a:p>
@@ -8887,7 +8970,7 @@
             <a:fld id="{B61BEF0D-F0BB-DE4B-95CE-6DB70DBA9567}" type="datetimeFigureOut">
               <a:rPr lang="en-US" dirty="0"/>
               <a:pPr/>
-              <a:t>4/30/2026</a:t>
+              <a:t>5/5/2026</a:t>
             </a:fld>
             <a:endParaRPr lang="en-US" dirty="0"/>
           </a:p>
@@ -9115,7 +9198,7 @@
           <a:p>
             <a:fld id="{EB712588-04B1-427B-82EE-E8DB90309F08}" type="datetimeFigureOut">
               <a:rPr lang="en-US" dirty="0"/>
-              <a:t>4/30/2026</a:t>
+              <a:t>5/5/2026</a:t>
             </a:fld>
             <a:endParaRPr lang="en-US" dirty="0"/>
           </a:p>
@@ -9485,7 +9568,7 @@
             <a:fld id="{B61BEF0D-F0BB-DE4B-95CE-6DB70DBA9567}" type="datetimeFigureOut">
               <a:rPr lang="en-US" dirty="0"/>
               <a:pPr/>
-              <a:t>4/30/2026</a:t>
+              <a:t>5/5/2026</a:t>
             </a:fld>
             <a:endParaRPr lang="en-US" dirty="0"/>
           </a:p>
@@ -9605,7 +9688,7 @@
             <a:fld id="{B61BEF0D-F0BB-DE4B-95CE-6DB70DBA9567}" type="datetimeFigureOut">
               <a:rPr lang="en-US" dirty="0"/>
               <a:pPr/>
-              <a:t>4/30/2026</a:t>
+              <a:t>5/5/2026</a:t>
             </a:fld>
             <a:endParaRPr lang="en-US" dirty="0"/>
           </a:p>
@@ -9697,7 +9780,7 @@
             <a:fld id="{B61BEF0D-F0BB-DE4B-95CE-6DB70DBA9567}" type="datetimeFigureOut">
               <a:rPr lang="en-US" dirty="0"/>
               <a:pPr/>
-              <a:t>4/30/2026</a:t>
+              <a:t>5/5/2026</a:t>
             </a:fld>
             <a:endParaRPr lang="en-US" dirty="0"/>
           </a:p>
@@ -9948,7 +10031,7 @@
           <a:p>
             <a:fld id="{42A54C80-263E-416B-A8E0-580EDEADCBDC}" type="datetimeFigureOut">
               <a:rPr lang="en-US" dirty="0"/>
-              <a:t>4/30/2026</a:t>
+              <a:t>5/5/2026</a:t>
             </a:fld>
             <a:endParaRPr lang="en-US" dirty="0"/>
           </a:p>
@@ -10207,7 +10290,7 @@
             <a:fld id="{B61BEF0D-F0BB-DE4B-95CE-6DB70DBA9567}" type="datetimeFigureOut">
               <a:rPr lang="en-US" dirty="0"/>
               <a:pPr/>
-              <a:t>4/30/2026</a:t>
+              <a:t>5/5/2026</a:t>
             </a:fld>
             <a:endParaRPr lang="en-US" dirty="0"/>
           </a:p>
@@ -10947,7 +11030,7 @@
             <a:fld id="{B61BEF0D-F0BB-DE4B-95CE-6DB70DBA9567}" type="datetimeFigureOut">
               <a:rPr lang="en-US" dirty="0"/>
               <a:pPr/>
-              <a:t>4/30/2026</a:t>
+              <a:t>5/5/2026</a:t>
             </a:fld>
             <a:endParaRPr lang="en-US" dirty="0"/>
           </a:p>
@@ -12294,6 +12377,756 @@
 </p:sld>
 </file>
 
+<file path=ppt/slides/slide6.xml><?xml version="1.0" encoding="utf-8"?>
+<p:sld xmlns:a="http://schemas.openxmlformats.org/drawingml/2006/main" xmlns:r="http://schemas.openxmlformats.org/officeDocument/2006/relationships" xmlns:p="http://schemas.openxmlformats.org/presentationml/2006/main">
+  <p:cSld>
+    <p:spTree>
+      <p:nvGrpSpPr>
+        <p:cNvPr id="1" name=""/>
+        <p:cNvGrpSpPr/>
+        <p:nvPr/>
+      </p:nvGrpSpPr>
+      <p:grpSpPr>
+        <a:xfrm>
+          <a:off x="0" y="0"/>
+          <a:ext cx="0" cy="0"/>
+          <a:chOff x="0" y="0"/>
+          <a:chExt cx="0" cy="0"/>
+        </a:xfrm>
+      </p:grpSpPr>
+      <p:graphicFrame>
+        <p:nvGraphicFramePr>
+          <p:cNvPr id="4" name="Table 3"/>
+          <p:cNvGraphicFramePr>
+            <a:graphicFrameLocks noGrp="1"/>
+          </p:cNvGraphicFramePr>
+          <p:nvPr>
+            <p:extLst>
+              <p:ext uri="{D42A27DB-BD31-4B8C-83A1-F6EECF244321}">
+                <p14:modId xmlns:p14="http://schemas.microsoft.com/office/powerpoint/2010/main" val="1382636809"/>
+              </p:ext>
+            </p:extLst>
+          </p:nvPr>
+        </p:nvGraphicFramePr>
+        <p:xfrm>
+          <a:off x="695460" y="270456"/>
+          <a:ext cx="5761149" cy="3145348"/>
+        </p:xfrm>
+        <a:graphic>
+          <a:graphicData uri="http://schemas.openxmlformats.org/drawingml/2006/table">
+            <a:tbl>
+              <a:tblPr>
+                <a:tableStyleId>{5C22544A-7EE6-4342-B048-85BDC9FD1C3A}</a:tableStyleId>
+              </a:tblPr>
+              <a:tblGrid>
+                <a:gridCol w="1920383"/>
+                <a:gridCol w="1920383"/>
+                <a:gridCol w="1920383"/>
+              </a:tblGrid>
+              <a:tr h="469845">
+                <a:tc>
+                  <a:txBody>
+                    <a:bodyPr/>
+                    <a:lstStyle/>
+                    <a:p>
+                      <a:pPr algn="l" fontAlgn="b"/>
+                      <a:r>
+                        <a:rPr lang="en-IN" sz="1800" u="none" strike="noStrike" dirty="0">
+                          <a:effectLst/>
+                        </a:rPr>
+                        <a:t>User Name</a:t>
+                      </a:r>
+                      <a:endParaRPr lang="en-IN" sz="1800" b="0" i="0" u="none" strike="noStrike" dirty="0">
+                        <a:solidFill>
+                          <a:srgbClr val="000000"/>
+                        </a:solidFill>
+                        <a:effectLst/>
+                        <a:latin typeface="Calibri" panose="020F0502020204030204" pitchFamily="34" charset="0"/>
+                      </a:endParaRPr>
+                    </a:p>
+                  </a:txBody>
+                  <a:tcPr marL="9525" marR="9525" marT="9525" marB="0" anchor="b"/>
+                </a:tc>
+                <a:tc>
+                  <a:txBody>
+                    <a:bodyPr/>
+                    <a:lstStyle/>
+                    <a:p>
+                      <a:pPr algn="l" fontAlgn="b"/>
+                      <a:r>
+                        <a:rPr lang="en-IN" sz="1800" u="none" strike="noStrike" dirty="0">
+                          <a:effectLst/>
+                        </a:rPr>
+                        <a:t>Password</a:t>
+                      </a:r>
+                      <a:endParaRPr lang="en-IN" sz="1800" b="0" i="0" u="none" strike="noStrike" dirty="0">
+                        <a:solidFill>
+                          <a:srgbClr val="000000"/>
+                        </a:solidFill>
+                        <a:effectLst/>
+                        <a:latin typeface="Calibri" panose="020F0502020204030204" pitchFamily="34" charset="0"/>
+                      </a:endParaRPr>
+                    </a:p>
+                  </a:txBody>
+                  <a:tcPr marL="9525" marR="9525" marT="9525" marB="0" anchor="b"/>
+                </a:tc>
+                <a:tc>
+                  <a:txBody>
+                    <a:bodyPr/>
+                    <a:lstStyle/>
+                    <a:p>
+                      <a:pPr algn="l" fontAlgn="b"/>
+                      <a:r>
+                        <a:rPr lang="en-IN" sz="1800" u="none" strike="noStrike">
+                          <a:effectLst/>
+                        </a:rPr>
+                        <a:t>Result</a:t>
+                      </a:r>
+                      <a:endParaRPr lang="en-IN" sz="1800" b="0" i="0" u="none" strike="noStrike">
+                        <a:solidFill>
+                          <a:srgbClr val="000000"/>
+                        </a:solidFill>
+                        <a:effectLst/>
+                        <a:latin typeface="Calibri" panose="020F0502020204030204" pitchFamily="34" charset="0"/>
+                      </a:endParaRPr>
+                    </a:p>
+                  </a:txBody>
+                  <a:tcPr marL="9525" marR="9525" marT="9525" marB="0" anchor="b"/>
+                </a:tc>
+              </a:tr>
+              <a:tr h="469845">
+                <a:tc>
+                  <a:txBody>
+                    <a:bodyPr/>
+                    <a:lstStyle/>
+                    <a:p>
+                      <a:pPr algn="l" fontAlgn="b"/>
+                      <a:r>
+                        <a:rPr lang="en-IN" sz="1800" u="none" strike="noStrike" dirty="0" err="1">
+                          <a:effectLst/>
+                        </a:rPr>
+                        <a:t>standard_user</a:t>
+                      </a:r>
+                      <a:endParaRPr lang="en-IN" sz="1800" b="0" i="0" u="none" strike="noStrike" dirty="0">
+                        <a:solidFill>
+                          <a:srgbClr val="000000"/>
+                        </a:solidFill>
+                        <a:effectLst/>
+                        <a:latin typeface="Calibri" panose="020F0502020204030204" pitchFamily="34" charset="0"/>
+                      </a:endParaRPr>
+                    </a:p>
+                  </a:txBody>
+                  <a:tcPr marL="9525" marR="9525" marT="9525" marB="0" anchor="b"/>
+                </a:tc>
+                <a:tc>
+                  <a:txBody>
+                    <a:bodyPr/>
+                    <a:lstStyle/>
+                    <a:p>
+                      <a:pPr algn="l" fontAlgn="b"/>
+                      <a:r>
+                        <a:rPr lang="en-IN" sz="1800" u="none" strike="noStrike">
+                          <a:effectLst/>
+                        </a:rPr>
+                        <a:t>secret_sauce</a:t>
+                      </a:r>
+                      <a:endParaRPr lang="en-IN" sz="1800" b="0" i="0" u="none" strike="noStrike">
+                        <a:solidFill>
+                          <a:srgbClr val="000000"/>
+                        </a:solidFill>
+                        <a:effectLst/>
+                        <a:latin typeface="Calibri" panose="020F0502020204030204" pitchFamily="34" charset="0"/>
+                      </a:endParaRPr>
+                    </a:p>
+                  </a:txBody>
+                  <a:tcPr marL="9525" marR="9525" marT="9525" marB="0" anchor="b"/>
+                </a:tc>
+                <a:tc>
+                  <a:txBody>
+                    <a:bodyPr/>
+                    <a:lstStyle/>
+                    <a:p>
+                      <a:pPr algn="l" fontAlgn="b"/>
+                      <a:r>
+                        <a:rPr lang="en-IN" sz="1800" u="none" strike="noStrike">
+                          <a:effectLst/>
+                        </a:rPr>
+                        <a:t>Not Run</a:t>
+                      </a:r>
+                      <a:endParaRPr lang="en-IN" sz="1800" b="0" i="0" u="none" strike="noStrike">
+                        <a:solidFill>
+                          <a:srgbClr val="000000"/>
+                        </a:solidFill>
+                        <a:effectLst/>
+                        <a:latin typeface="Calibri" panose="020F0502020204030204" pitchFamily="34" charset="0"/>
+                      </a:endParaRPr>
+                    </a:p>
+                  </a:txBody>
+                  <a:tcPr marL="9525" marR="9525" marT="9525" marB="0" anchor="b"/>
+                </a:tc>
+              </a:tr>
+              <a:tr h="469845">
+                <a:tc>
+                  <a:txBody>
+                    <a:bodyPr/>
+                    <a:lstStyle/>
+                    <a:p>
+                      <a:pPr algn="l" fontAlgn="b"/>
+                      <a:r>
+                        <a:rPr lang="en-IN" sz="1800" u="none" strike="noStrike" dirty="0" err="1">
+                          <a:effectLst/>
+                        </a:rPr>
+                        <a:t>dilshad</a:t>
+                      </a:r>
+                      <a:endParaRPr lang="en-IN" sz="1800" b="0" i="0" u="none" strike="noStrike" dirty="0">
+                        <a:solidFill>
+                          <a:srgbClr val="000000"/>
+                        </a:solidFill>
+                        <a:effectLst/>
+                        <a:latin typeface="Calibri" panose="020F0502020204030204" pitchFamily="34" charset="0"/>
+                      </a:endParaRPr>
+                    </a:p>
+                  </a:txBody>
+                  <a:tcPr marL="9525" marR="9525" marT="9525" marB="0" anchor="b"/>
+                </a:tc>
+                <a:tc>
+                  <a:txBody>
+                    <a:bodyPr/>
+                    <a:lstStyle/>
+                    <a:p>
+                      <a:pPr algn="l" fontAlgn="b"/>
+                      <a:r>
+                        <a:rPr lang="en-IN" sz="1800" u="none" strike="noStrike">
+                          <a:effectLst/>
+                        </a:rPr>
+                        <a:t>dishad123</a:t>
+                      </a:r>
+                      <a:endParaRPr lang="en-IN" sz="1800" b="0" i="0" u="none" strike="noStrike">
+                        <a:solidFill>
+                          <a:srgbClr val="000000"/>
+                        </a:solidFill>
+                        <a:effectLst/>
+                        <a:latin typeface="Calibri" panose="020F0502020204030204" pitchFamily="34" charset="0"/>
+                      </a:endParaRPr>
+                    </a:p>
+                  </a:txBody>
+                  <a:tcPr marL="9525" marR="9525" marT="9525" marB="0" anchor="b"/>
+                </a:tc>
+                <a:tc>
+                  <a:txBody>
+                    <a:bodyPr/>
+                    <a:lstStyle/>
+                    <a:p>
+                      <a:pPr algn="l" fontAlgn="b"/>
+                      <a:r>
+                        <a:rPr lang="en-IN" sz="1800" u="none" strike="noStrike">
+                          <a:effectLst/>
+                        </a:rPr>
+                        <a:t>Not Run</a:t>
+                      </a:r>
+                      <a:endParaRPr lang="en-IN" sz="1800" b="0" i="0" u="none" strike="noStrike">
+                        <a:solidFill>
+                          <a:srgbClr val="000000"/>
+                        </a:solidFill>
+                        <a:effectLst/>
+                        <a:latin typeface="Calibri" panose="020F0502020204030204" pitchFamily="34" charset="0"/>
+                      </a:endParaRPr>
+                    </a:p>
+                  </a:txBody>
+                  <a:tcPr marL="9525" marR="9525" marT="9525" marB="0" anchor="b"/>
+                </a:tc>
+              </a:tr>
+              <a:tr h="698278">
+                <a:tc>
+                  <a:txBody>
+                    <a:bodyPr/>
+                    <a:lstStyle/>
+                    <a:p>
+                      <a:pPr algn="l" fontAlgn="b"/>
+                      <a:r>
+                        <a:rPr lang="en-IN" sz="1800" u="none" strike="noStrike" dirty="0" err="1">
+                          <a:effectLst/>
+                        </a:rPr>
+                        <a:t>performance_glitch_user</a:t>
+                      </a:r>
+                      <a:endParaRPr lang="en-IN" sz="1800" b="0" i="0" u="none" strike="noStrike" dirty="0">
+                        <a:solidFill>
+                          <a:srgbClr val="000000"/>
+                        </a:solidFill>
+                        <a:effectLst/>
+                        <a:latin typeface="Calibri" panose="020F0502020204030204" pitchFamily="34" charset="0"/>
+                      </a:endParaRPr>
+                    </a:p>
+                  </a:txBody>
+                  <a:tcPr marL="9525" marR="9525" marT="9525" marB="0" anchor="b"/>
+                </a:tc>
+                <a:tc>
+                  <a:txBody>
+                    <a:bodyPr/>
+                    <a:lstStyle/>
+                    <a:p>
+                      <a:pPr algn="l" fontAlgn="b"/>
+                      <a:r>
+                        <a:rPr lang="en-IN" sz="1800" u="none" strike="noStrike">
+                          <a:effectLst/>
+                        </a:rPr>
+                        <a:t>secret_sauce</a:t>
+                      </a:r>
+                      <a:endParaRPr lang="en-IN" sz="1800" b="0" i="0" u="none" strike="noStrike">
+                        <a:solidFill>
+                          <a:srgbClr val="000000"/>
+                        </a:solidFill>
+                        <a:effectLst/>
+                        <a:latin typeface="Calibri" panose="020F0502020204030204" pitchFamily="34" charset="0"/>
+                      </a:endParaRPr>
+                    </a:p>
+                  </a:txBody>
+                  <a:tcPr marL="9525" marR="9525" marT="9525" marB="0" anchor="b"/>
+                </a:tc>
+                <a:tc>
+                  <a:txBody>
+                    <a:bodyPr/>
+                    <a:lstStyle/>
+                    <a:p>
+                      <a:pPr algn="l" fontAlgn="b"/>
+                      <a:r>
+                        <a:rPr lang="en-IN" sz="1800" u="none" strike="noStrike">
+                          <a:effectLst/>
+                        </a:rPr>
+                        <a:t>Not Run</a:t>
+                      </a:r>
+                      <a:endParaRPr lang="en-IN" sz="1800" b="0" i="0" u="none" strike="noStrike">
+                        <a:solidFill>
+                          <a:srgbClr val="000000"/>
+                        </a:solidFill>
+                        <a:effectLst/>
+                        <a:latin typeface="Calibri" panose="020F0502020204030204" pitchFamily="34" charset="0"/>
+                      </a:endParaRPr>
+                    </a:p>
+                  </a:txBody>
+                  <a:tcPr marL="9525" marR="9525" marT="9525" marB="0" anchor="b"/>
+                </a:tc>
+              </a:tr>
+              <a:tr h="259583">
+                <a:tc>
+                  <a:txBody>
+                    <a:bodyPr/>
+                    <a:lstStyle/>
+                    <a:p>
+                      <a:pPr algn="l" fontAlgn="b"/>
+                      <a:r>
+                        <a:rPr lang="en-IN" sz="1800" u="none" strike="noStrike" dirty="0" err="1">
+                          <a:effectLst/>
+                        </a:rPr>
+                        <a:t>priyanka</a:t>
+                      </a:r>
+                      <a:endParaRPr lang="en-IN" sz="1800" b="0" i="0" u="none" strike="noStrike" dirty="0">
+                        <a:solidFill>
+                          <a:srgbClr val="000000"/>
+                        </a:solidFill>
+                        <a:effectLst/>
+                        <a:latin typeface="Calibri" panose="020F0502020204030204" pitchFamily="34" charset="0"/>
+                      </a:endParaRPr>
+                    </a:p>
+                  </a:txBody>
+                  <a:tcPr marL="9525" marR="9525" marT="9525" marB="0" anchor="b"/>
+                </a:tc>
+                <a:tc>
+                  <a:txBody>
+                    <a:bodyPr/>
+                    <a:lstStyle/>
+                    <a:p>
+                      <a:pPr algn="l" fontAlgn="b"/>
+                      <a:r>
+                        <a:rPr lang="en-IN" sz="1800" u="none" strike="noStrike">
+                          <a:effectLst/>
+                        </a:rPr>
+                        <a:t>priyanka</a:t>
+                      </a:r>
+                      <a:endParaRPr lang="en-IN" sz="1800" b="0" i="0" u="none" strike="noStrike">
+                        <a:solidFill>
+                          <a:srgbClr val="000000"/>
+                        </a:solidFill>
+                        <a:effectLst/>
+                        <a:latin typeface="Calibri" panose="020F0502020204030204" pitchFamily="34" charset="0"/>
+                      </a:endParaRPr>
+                    </a:p>
+                  </a:txBody>
+                  <a:tcPr marL="9525" marR="9525" marT="9525" marB="0" anchor="b"/>
+                </a:tc>
+                <a:tc>
+                  <a:txBody>
+                    <a:bodyPr/>
+                    <a:lstStyle/>
+                    <a:p>
+                      <a:pPr algn="l" fontAlgn="b"/>
+                      <a:r>
+                        <a:rPr lang="en-IN" sz="1800" u="none" strike="noStrike">
+                          <a:effectLst/>
+                        </a:rPr>
+                        <a:t>Not Run</a:t>
+                      </a:r>
+                      <a:endParaRPr lang="en-IN" sz="1800" b="0" i="0" u="none" strike="noStrike">
+                        <a:solidFill>
+                          <a:srgbClr val="000000"/>
+                        </a:solidFill>
+                        <a:effectLst/>
+                        <a:latin typeface="Calibri" panose="020F0502020204030204" pitchFamily="34" charset="0"/>
+                      </a:endParaRPr>
+                    </a:p>
+                  </a:txBody>
+                  <a:tcPr marL="9525" marR="9525" marT="9525" marB="0" anchor="b"/>
+                </a:tc>
+              </a:tr>
+              <a:tr h="469845">
+                <a:tc>
+                  <a:txBody>
+                    <a:bodyPr/>
+                    <a:lstStyle/>
+                    <a:p>
+                      <a:pPr algn="l" fontAlgn="b"/>
+                      <a:r>
+                        <a:rPr lang="en-IN" sz="1800" u="none" strike="noStrike" dirty="0" err="1">
+                          <a:effectLst/>
+                        </a:rPr>
+                        <a:t>visual_user</a:t>
+                      </a:r>
+                      <a:endParaRPr lang="en-IN" sz="1800" b="0" i="0" u="none" strike="noStrike" dirty="0">
+                        <a:solidFill>
+                          <a:srgbClr val="000000"/>
+                        </a:solidFill>
+                        <a:effectLst/>
+                        <a:latin typeface="Calibri" panose="020F0502020204030204" pitchFamily="34" charset="0"/>
+                      </a:endParaRPr>
+                    </a:p>
+                  </a:txBody>
+                  <a:tcPr marL="9525" marR="9525" marT="9525" marB="0" anchor="b"/>
+                </a:tc>
+                <a:tc>
+                  <a:txBody>
+                    <a:bodyPr/>
+                    <a:lstStyle/>
+                    <a:p>
+                      <a:pPr algn="l" fontAlgn="b"/>
+                      <a:r>
+                        <a:rPr lang="en-IN" sz="1800" u="none" strike="noStrike">
+                          <a:effectLst/>
+                        </a:rPr>
+                        <a:t>secret_sauce</a:t>
+                      </a:r>
+                      <a:endParaRPr lang="en-IN" sz="1800" b="0" i="0" u="none" strike="noStrike">
+                        <a:solidFill>
+                          <a:srgbClr val="000000"/>
+                        </a:solidFill>
+                        <a:effectLst/>
+                        <a:latin typeface="Calibri" panose="020F0502020204030204" pitchFamily="34" charset="0"/>
+                      </a:endParaRPr>
+                    </a:p>
+                  </a:txBody>
+                  <a:tcPr marL="9525" marR="9525" marT="9525" marB="0" anchor="b"/>
+                </a:tc>
+                <a:tc>
+                  <a:txBody>
+                    <a:bodyPr/>
+                    <a:lstStyle/>
+                    <a:p>
+                      <a:pPr algn="l" fontAlgn="b"/>
+                      <a:r>
+                        <a:rPr lang="en-IN" sz="1800" u="none" strike="noStrike">
+                          <a:effectLst/>
+                        </a:rPr>
+                        <a:t>Not Run</a:t>
+                      </a:r>
+                      <a:endParaRPr lang="en-IN" sz="1800" b="0" i="0" u="none" strike="noStrike">
+                        <a:solidFill>
+                          <a:srgbClr val="000000"/>
+                        </a:solidFill>
+                        <a:effectLst/>
+                        <a:latin typeface="Calibri" panose="020F0502020204030204" pitchFamily="34" charset="0"/>
+                      </a:endParaRPr>
+                    </a:p>
+                  </a:txBody>
+                  <a:tcPr marL="9525" marR="9525" marT="9525" marB="0" anchor="b"/>
+                </a:tc>
+              </a:tr>
+              <a:tr h="259583">
+                <a:tc>
+                  <a:txBody>
+                    <a:bodyPr/>
+                    <a:lstStyle/>
+                    <a:p>
+                      <a:pPr algn="l" fontAlgn="b"/>
+                      <a:r>
+                        <a:rPr lang="en-IN" sz="1800" u="none" strike="noStrike" dirty="0" err="1">
+                          <a:effectLst/>
+                        </a:rPr>
+                        <a:t>ayush</a:t>
+                      </a:r>
+                      <a:endParaRPr lang="en-IN" sz="1800" b="0" i="0" u="none" strike="noStrike" dirty="0">
+                        <a:solidFill>
+                          <a:srgbClr val="000000"/>
+                        </a:solidFill>
+                        <a:effectLst/>
+                        <a:latin typeface="Calibri" panose="020F0502020204030204" pitchFamily="34" charset="0"/>
+                      </a:endParaRPr>
+                    </a:p>
+                  </a:txBody>
+                  <a:tcPr marL="9525" marR="9525" marT="9525" marB="0" anchor="b"/>
+                </a:tc>
+                <a:tc>
+                  <a:txBody>
+                    <a:bodyPr/>
+                    <a:lstStyle/>
+                    <a:p>
+                      <a:pPr algn="l" fontAlgn="b"/>
+                      <a:r>
+                        <a:rPr lang="en-IN" sz="1800" u="none" strike="noStrike">
+                          <a:effectLst/>
+                        </a:rPr>
+                        <a:t>ayush123</a:t>
+                      </a:r>
+                      <a:endParaRPr lang="en-IN" sz="1800" b="0" i="0" u="none" strike="noStrike">
+                        <a:solidFill>
+                          <a:srgbClr val="000000"/>
+                        </a:solidFill>
+                        <a:effectLst/>
+                        <a:latin typeface="Calibri" panose="020F0502020204030204" pitchFamily="34" charset="0"/>
+                      </a:endParaRPr>
+                    </a:p>
+                  </a:txBody>
+                  <a:tcPr marL="9525" marR="9525" marT="9525" marB="0" anchor="b"/>
+                </a:tc>
+                <a:tc>
+                  <a:txBody>
+                    <a:bodyPr/>
+                    <a:lstStyle/>
+                    <a:p>
+                      <a:pPr algn="l" fontAlgn="b"/>
+                      <a:r>
+                        <a:rPr lang="en-IN" sz="1800" u="none" strike="noStrike" dirty="0">
+                          <a:effectLst/>
+                        </a:rPr>
+                        <a:t>Not Run</a:t>
+                      </a:r>
+                      <a:endParaRPr lang="en-IN" sz="1800" b="0" i="0" u="none" strike="noStrike" dirty="0">
+                        <a:solidFill>
+                          <a:srgbClr val="000000"/>
+                        </a:solidFill>
+                        <a:effectLst/>
+                        <a:latin typeface="Calibri" panose="020F0502020204030204" pitchFamily="34" charset="0"/>
+                      </a:endParaRPr>
+                    </a:p>
+                  </a:txBody>
+                  <a:tcPr marL="9525" marR="9525" marT="9525" marB="0" anchor="b"/>
+                </a:tc>
+              </a:tr>
+            </a:tbl>
+          </a:graphicData>
+        </a:graphic>
+      </p:graphicFrame>
+      <p:graphicFrame>
+        <p:nvGraphicFramePr>
+          <p:cNvPr id="5" name="Table 4"/>
+          <p:cNvGraphicFramePr>
+            <a:graphicFrameLocks noGrp="1"/>
+          </p:cNvGraphicFramePr>
+          <p:nvPr>
+            <p:extLst>
+              <p:ext uri="{D42A27DB-BD31-4B8C-83A1-F6EECF244321}">
+                <p14:modId xmlns:p14="http://schemas.microsoft.com/office/powerpoint/2010/main" val="1469632017"/>
+              </p:ext>
+            </p:extLst>
+          </p:nvPr>
+        </p:nvGraphicFramePr>
+        <p:xfrm>
+          <a:off x="563809" y="3836353"/>
+          <a:ext cx="5418666" cy="2595880"/>
+        </p:xfrm>
+        <a:graphic>
+          <a:graphicData uri="http://schemas.openxmlformats.org/drawingml/2006/table">
+            <a:tbl>
+              <a:tblPr firstRow="1" bandRow="1">
+                <a:tableStyleId>{5940675A-B579-460E-94D1-54222C63F5DA}</a:tableStyleId>
+              </a:tblPr>
+              <a:tblGrid>
+                <a:gridCol w="2709333"/>
+                <a:gridCol w="2709333"/>
+              </a:tblGrid>
+              <a:tr h="370840">
+                <a:tc>
+                  <a:txBody>
+                    <a:bodyPr/>
+                    <a:lstStyle/>
+                    <a:p>
+                      <a:endParaRPr lang="en-IN" dirty="0"/>
+                    </a:p>
+                  </a:txBody>
+                  <a:tcPr/>
+                </a:tc>
+                <a:tc>
+                  <a:txBody>
+                    <a:bodyPr/>
+                    <a:lstStyle/>
+                    <a:p>
+                      <a:endParaRPr lang="en-IN" dirty="0"/>
+                    </a:p>
+                  </a:txBody>
+                  <a:tcPr/>
+                </a:tc>
+              </a:tr>
+              <a:tr h="370840">
+                <a:tc>
+                  <a:txBody>
+                    <a:bodyPr/>
+                    <a:lstStyle/>
+                    <a:p>
+                      <a:r>
+                        <a:rPr lang="en-US" dirty="0" err="1" smtClean="0"/>
+                        <a:t>jjhjh</a:t>
+                      </a:r>
+                      <a:endParaRPr lang="en-IN" dirty="0"/>
+                    </a:p>
+                  </a:txBody>
+                  <a:tcPr/>
+                </a:tc>
+                <a:tc>
+                  <a:txBody>
+                    <a:bodyPr/>
+                    <a:lstStyle/>
+                    <a:p>
+                      <a:endParaRPr lang="en-IN"/>
+                    </a:p>
+                  </a:txBody>
+                  <a:tcPr/>
+                </a:tc>
+              </a:tr>
+              <a:tr h="370840">
+                <a:tc>
+                  <a:txBody>
+                    <a:bodyPr/>
+                    <a:lstStyle/>
+                    <a:p>
+                      <a:endParaRPr lang="en-IN"/>
+                    </a:p>
+                  </a:txBody>
+                  <a:tcPr/>
+                </a:tc>
+                <a:tc>
+                  <a:txBody>
+                    <a:bodyPr/>
+                    <a:lstStyle/>
+                    <a:p>
+                      <a:endParaRPr lang="en-IN"/>
+                    </a:p>
+                  </a:txBody>
+                  <a:tcPr/>
+                </a:tc>
+              </a:tr>
+              <a:tr h="370840">
+                <a:tc>
+                  <a:txBody>
+                    <a:bodyPr/>
+                    <a:lstStyle/>
+                    <a:p>
+                      <a:endParaRPr lang="en-IN"/>
+                    </a:p>
+                  </a:txBody>
+                  <a:tcPr/>
+                </a:tc>
+                <a:tc>
+                  <a:txBody>
+                    <a:bodyPr/>
+                    <a:lstStyle/>
+                    <a:p>
+                      <a:endParaRPr lang="en-IN"/>
+                    </a:p>
+                  </a:txBody>
+                  <a:tcPr/>
+                </a:tc>
+              </a:tr>
+              <a:tr h="370840">
+                <a:tc>
+                  <a:txBody>
+                    <a:bodyPr/>
+                    <a:lstStyle/>
+                    <a:p>
+                      <a:endParaRPr lang="en-IN"/>
+                    </a:p>
+                  </a:txBody>
+                  <a:tcPr/>
+                </a:tc>
+                <a:tc>
+                  <a:txBody>
+                    <a:bodyPr/>
+                    <a:lstStyle/>
+                    <a:p>
+                      <a:endParaRPr lang="en-IN"/>
+                    </a:p>
+                  </a:txBody>
+                  <a:tcPr/>
+                </a:tc>
+              </a:tr>
+              <a:tr h="370840">
+                <a:tc>
+                  <a:txBody>
+                    <a:bodyPr/>
+                    <a:lstStyle/>
+                    <a:p>
+                      <a:endParaRPr lang="en-IN"/>
+                    </a:p>
+                  </a:txBody>
+                  <a:tcPr/>
+                </a:tc>
+                <a:tc>
+                  <a:txBody>
+                    <a:bodyPr/>
+                    <a:lstStyle/>
+                    <a:p>
+                      <a:endParaRPr lang="en-IN"/>
+                    </a:p>
+                  </a:txBody>
+                  <a:tcPr/>
+                </a:tc>
+              </a:tr>
+              <a:tr h="370840">
+                <a:tc>
+                  <a:txBody>
+                    <a:bodyPr/>
+                    <a:lstStyle/>
+                    <a:p>
+                      <a:endParaRPr lang="en-IN"/>
+                    </a:p>
+                  </a:txBody>
+                  <a:tcPr/>
+                </a:tc>
+                <a:tc>
+                  <a:txBody>
+                    <a:bodyPr/>
+                    <a:lstStyle/>
+                    <a:p>
+                      <a:endParaRPr lang="en-IN" dirty="0"/>
+                    </a:p>
+                  </a:txBody>
+                  <a:tcPr/>
+                </a:tc>
+              </a:tr>
+            </a:tbl>
+          </a:graphicData>
+        </a:graphic>
+      </p:graphicFrame>
+    </p:spTree>
+    <p:extLst>
+      <p:ext uri="{BB962C8B-B14F-4D97-AF65-F5344CB8AC3E}">
+        <p14:creationId xmlns:p14="http://schemas.microsoft.com/office/powerpoint/2010/main" val="2969582978"/>
+      </p:ext>
+    </p:extLst>
+  </p:cSld>
+  <p:clrMapOvr>
+    <a:masterClrMapping/>
+  </p:clrMapOvr>
+</p:sld>
+</file>
+
 <file path=ppt/theme/theme1.xml><?xml version="1.0" encoding="utf-8"?>
 <a:theme xmlns:a="http://schemas.openxmlformats.org/drawingml/2006/main" name="Facet">
   <a:themeElements>

</xml_diff>